<commit_message>
Priorities slide: drop connecting line and cascade wording, documents are parallel
Co-Authored-By: Claude Sonnet 5.5 <noreply@anthropic.com>
Claude-Session: https://claude.ai/code/session_01PfagTkBBfn3ShTm5bX9M45
</commit_message>
<xml_diff>
--- a/slide_prioritety_dokumenty.pptx
+++ b/slide_prioritety_dokumenty.pptx
@@ -6289,7 +6289,7 @@
                 </a:solidFill>
                 <a:latin typeface="Circe"/>
               </a:rPr>
-              <a:t>Документы стратегического планирования: от стратегии НТР к отраслевым планам импортозамещения</a:t>
+              <a:t>Основные документы, которые определяют приоритеты и механизмы технологического развития России</a:t>
             </a:r>
             <a:endParaRPr sz="2200" b="0" dirty="0">
               <a:solidFill>
@@ -6453,30 +6453,9 @@
           </a:p>
         </p:txBody>
       </p:sp>
-      <p:cxnSp>
-        <p:nvCxnSpPr>
-          <p:cNvPr id="208" name="Связка документов"/>
-          <p:cNvCxnSpPr/>
-          <p:nvPr/>
-        </p:nvCxnSpPr>
-        <p:spPr>
-          <a:xfrm>
-            <a:off x="1755648" y="3374136"/>
-            <a:ext cx="0" cy="5303520"/>
-          </a:xfrm>
-          <a:prstGeom prst="line">
-            <a:avLst/>
-          </a:prstGeom>
-          <a:ln w="19050">
-            <a:solidFill>
-              <a:srgbClr val="062D3F"/>
-            </a:solidFill>
-          </a:ln>
-        </p:spPr>
-      </p:cxnSp>
       <p:sp>
         <p:nvSpPr>
-          <p:cNvPr id="209" name="Номер 1"/>
+          <p:cNvPr id="208" name="Номер 1"/>
           <p:cNvSpPr/>
           <p:nvPr/>
         </p:nvSpPr>
@@ -6514,7 +6493,7 @@
       </p:sp>
       <p:sp>
         <p:nvSpPr>
-          <p:cNvPr id="210" name="Документ 1"/>
+          <p:cNvPr id="209" name="Документ 1"/>
           <p:cNvSpPr txBox="1"/>
           <p:nvPr/>
         </p:nvSpPr>
@@ -6565,7 +6544,7 @@
       </p:sp>
       <p:sp>
         <p:nvSpPr>
-          <p:cNvPr id="211" name="Описание 1"/>
+          <p:cNvPr id="210" name="Описание 1"/>
           <p:cNvSpPr txBox="1"/>
           <p:nvPr/>
         </p:nvSpPr>
@@ -6600,7 +6579,7 @@
       </p:sp>
       <p:sp>
         <p:nvSpPr>
-          <p:cNvPr id="212" name="Номер 2"/>
+          <p:cNvPr id="211" name="Номер 2"/>
           <p:cNvSpPr/>
           <p:nvPr/>
         </p:nvSpPr>
@@ -6638,7 +6617,7 @@
       </p:sp>
       <p:sp>
         <p:nvSpPr>
-          <p:cNvPr id="213" name="Документ 2"/>
+          <p:cNvPr id="212" name="Документ 2"/>
           <p:cNvSpPr txBox="1"/>
           <p:nvPr/>
         </p:nvSpPr>
@@ -6689,7 +6668,7 @@
       </p:sp>
       <p:sp>
         <p:nvSpPr>
-          <p:cNvPr id="214" name="Описание 2"/>
+          <p:cNvPr id="213" name="Описание 2"/>
           <p:cNvSpPr txBox="1"/>
           <p:nvPr/>
         </p:nvSpPr>
@@ -6724,7 +6703,7 @@
       </p:sp>
       <p:sp>
         <p:nvSpPr>
-          <p:cNvPr id="215" name="Номер 3"/>
+          <p:cNvPr id="214" name="Номер 3"/>
           <p:cNvSpPr/>
           <p:nvPr/>
         </p:nvSpPr>
@@ -6762,7 +6741,7 @@
       </p:sp>
       <p:sp>
         <p:nvSpPr>
-          <p:cNvPr id="216" name="Документ 3"/>
+          <p:cNvPr id="215" name="Документ 3"/>
           <p:cNvSpPr txBox="1"/>
           <p:nvPr/>
         </p:nvSpPr>
@@ -6813,7 +6792,7 @@
       </p:sp>
       <p:sp>
         <p:nvSpPr>
-          <p:cNvPr id="217" name="Описание 3"/>
+          <p:cNvPr id="216" name="Описание 3"/>
           <p:cNvSpPr txBox="1"/>
           <p:nvPr/>
         </p:nvSpPr>
@@ -6848,7 +6827,7 @@
       </p:sp>
       <p:cxnSp>
         <p:nvCxnSpPr>
-          <p:cNvPr id="218" name="Разделитель"/>
+          <p:cNvPr id="217" name="Разделитель"/>
           <p:cNvCxnSpPr/>
           <p:nvPr/>
         </p:nvCxnSpPr>
@@ -6869,7 +6848,7 @@
       </p:cxnSp>
       <p:sp>
         <p:nvSpPr>
-          <p:cNvPr id="219" name="Номер 4"/>
+          <p:cNvPr id="218" name="Номер 4"/>
           <p:cNvSpPr/>
           <p:nvPr/>
         </p:nvSpPr>
@@ -6907,7 +6886,7 @@
       </p:sp>
       <p:sp>
         <p:nvSpPr>
-          <p:cNvPr id="220" name="Документ 4"/>
+          <p:cNvPr id="219" name="Документ 4"/>
           <p:cNvSpPr txBox="1"/>
           <p:nvPr/>
         </p:nvSpPr>
@@ -6958,7 +6937,7 @@
       </p:sp>
       <p:sp>
         <p:nvSpPr>
-          <p:cNvPr id="221" name="Описание 4"/>
+          <p:cNvPr id="220" name="Описание 4"/>
           <p:cNvSpPr txBox="1"/>
           <p:nvPr/>
         </p:nvSpPr>
@@ -6993,7 +6972,7 @@
       </p:sp>
       <p:cxnSp>
         <p:nvCxnSpPr>
-          <p:cNvPr id="222" name="Разделитель"/>
+          <p:cNvPr id="221" name="Разделитель"/>
           <p:cNvCxnSpPr/>
           <p:nvPr/>
         </p:nvCxnSpPr>
@@ -7014,7 +6993,7 @@
       </p:cxnSp>
       <p:sp>
         <p:nvSpPr>
-          <p:cNvPr id="223" name="Номер 5"/>
+          <p:cNvPr id="222" name="Номер 5"/>
           <p:cNvSpPr/>
           <p:nvPr/>
         </p:nvSpPr>
@@ -7052,7 +7031,7 @@
       </p:sp>
       <p:sp>
         <p:nvSpPr>
-          <p:cNvPr id="224" name="Документ 5"/>
+          <p:cNvPr id="223" name="Документ 5"/>
           <p:cNvSpPr txBox="1"/>
           <p:nvPr/>
         </p:nvSpPr>
@@ -7087,7 +7066,7 @@
       </p:sp>
       <p:sp>
         <p:nvSpPr>
-          <p:cNvPr id="225" name="Пояснение"/>
+          <p:cNvPr id="224" name="Пояснение"/>
           <p:cNvSpPr txBox="1"/>
           <p:nvPr/>
         </p:nvSpPr>

</xml_diff>

<commit_message>
Priorities slide: add description for item 5
Co-Authored-By: Claude Sonnet 5.5 <noreply@anthropic.com>
Claude-Session: https://claude.ai/code/session_01PfagTkBBfn3ShTm5bX9M45
</commit_message>
<xml_diff>
--- a/slide_prioritety_dokumenty.pptx
+++ b/slide_prioritety_dokumenty.pptx
@@ -430,7 +430,7 @@
           <a:lstStyle/>
           <a:p>
             <a:r>
-              <a:t>Слайд пересобран из растрового рисунка (бывший слайд 22). На исходном рисунке нумерация была 1, 2, 4, 4, 5; здесь исправлена на 1–5. В описании пункта 4 убран обрывок текста «участников в процесс планирования (бизнес-жители)», попавший в рисунок по ошибке. Название пункта 4 исправлено с «Сводная стратегии» на «Сводная стратегия»; срок «до 2030–2035» оставлен как на исходном рисунке, его нужно сверить с распоряжением № 1512-р. Подсветка пунктов 1 и 2 добавлена при оформлении: на них ссылается слайд про критические и сквозные технологии (Указы № 145 и № 529).</a:t>
+              <a:t>Слайд пересобран из растрового рисунка (бывший слайд 22). На исходном рисунке нумерация была 1, 2, 4, 4, 5; здесь исправлена на 1–5. В описании пункта 4 убран обрывок текста «участников в процесс планирования (бизнес-жители)», попавший в рисунок по ошибке. Название пункта 4 исправлено с «Сводная стратегии» на «Сводная стратегия»; срок «до 2030–2035» оставлен как на исходном рисунке, его нужно сверить с распоряжением № 1512-р. Описание пункта 5 на исходном рисунке отсутствовало и написано при оформлении (по общим сведениям об отраслевых планах импортозамещения). Подсветка пунктов 1 и 2 добавлена при оформлении: на них ссылается слайд про критические и сквозные технологии (Указы № 145 и № 529).</a:t>
             </a:r>
           </a:p>
         </p:txBody>
@@ -7066,7 +7066,42 @@
       </p:sp>
       <p:sp>
         <p:nvSpPr>
-          <p:cNvPr id="224" name="Пояснение"/>
+          <p:cNvPr id="224" name="Описание 5"/>
+          <p:cNvSpPr txBox="1"/>
+          <p:nvPr/>
+        </p:nvSpPr>
+        <p:spPr>
+          <a:xfrm>
+            <a:off x="10149840" y="8156448"/>
+            <a:ext cx="7516367" cy="1042415"/>
+          </a:xfrm>
+          <a:prstGeom prst="rect">
+            <a:avLst/>
+          </a:prstGeom>
+          <a:noFill/>
+        </p:spPr>
+        <p:txBody>
+          <a:bodyPr wrap="square" anchor="ctr" lIns="0" rIns="0" tIns="0" bIns="0">
+            <a:spAutoFit/>
+          </a:bodyPr>
+          <a:lstStyle/>
+          <a:p>
+            <a:pPr algn="l"/>
+            <a:r>
+              <a:rPr sz="1700" b="0">
+                <a:solidFill>
+                  <a:srgbClr val="062D3F"/>
+                </a:solidFill>
+                <a:latin typeface="Circe"/>
+              </a:rPr>
+              <a:t>Устанавливают перечни импортозамещаемой продукции, сроки и целевые показатели замещения по отраслям промышленности</a:t>
+            </a:r>
+          </a:p>
+        </p:txBody>
+      </p:sp>
+      <p:sp>
+        <p:nvSpPr>
+          <p:cNvPr id="225" name="Пояснение"/>
           <p:cNvSpPr txBox="1"/>
           <p:nvPr/>
         </p:nvSpPr>

</xml_diff>